<commit_message>
Use genuine PreLec sources for Week 5, revert L5.2 to placeholder
L5.1 now uses raw/AICE2005_Week5_L1_PreLec.pptx (the real pre-lecture
deck) instead of the non-PreLec Lecture file used previously. L5.2's
real pre-lecture source is still 510MB (embedded video) and can't be
pushed to GitHub, so its PPTX/PDF are removed and the week page falls
back to a placeholder; only the Recording link remains.

Co-Authored-By: Claude Sonnet 5 <noreply@anthropic.com>
</commit_message>
<xml_diff>
--- a/html/COMP-_L5.1_PreLec.pptx
+++ b/html/COMP-_L5.1_PreLec.pptx
@@ -223,7 +223,7 @@
           <a:p>
             <a:fld id="{5B3C0760-A542-FE4F-8EBF-B1B1FB6407CD}" type="datetimeFigureOut">
               <a:rPr lang="en-001" smtClean="0"/>
-              <a:t>12/10/2026</a:t>
+              <a:t>07/10/2026</a:t>
             </a:fld>
             <a:endParaRPr lang="en-001"/>
           </a:p>
@@ -670,7 +670,7 @@
           <a:p>
             <a:fld id="{5BCAD085-E8A6-8845-BD4E-CB4CCA059FC4}" type="datetimeFigureOut">
               <a:rPr lang="en-US" smtClean="0"/>
-              <a:t>10/12/26</a:t>
+              <a:t>10/7/26</a:t>
             </a:fld>
             <a:endParaRPr lang="en-US"/>
           </a:p>
@@ -838,7 +838,7 @@
           <a:p>
             <a:fld id="{5BCAD085-E8A6-8845-BD4E-CB4CCA059FC4}" type="datetimeFigureOut">
               <a:rPr lang="en-US" smtClean="0"/>
-              <a:t>10/12/26</a:t>
+              <a:t>10/7/26</a:t>
             </a:fld>
             <a:endParaRPr lang="en-US"/>
           </a:p>
@@ -1016,7 +1016,7 @@
           <a:p>
             <a:fld id="{5BCAD085-E8A6-8845-BD4E-CB4CCA059FC4}" type="datetimeFigureOut">
               <a:rPr lang="en-US" smtClean="0"/>
-              <a:t>10/12/26</a:t>
+              <a:t>10/7/26</a:t>
             </a:fld>
             <a:endParaRPr lang="en-US"/>
           </a:p>
@@ -1184,7 +1184,7 @@
           <a:p>
             <a:fld id="{5BCAD085-E8A6-8845-BD4E-CB4CCA059FC4}" type="datetimeFigureOut">
               <a:rPr lang="en-US" smtClean="0"/>
-              <a:t>10/12/26</a:t>
+              <a:t>10/7/26</a:t>
             </a:fld>
             <a:endParaRPr lang="en-US"/>
           </a:p>
@@ -1429,7 +1429,7 @@
           <a:p>
             <a:fld id="{5BCAD085-E8A6-8845-BD4E-CB4CCA059FC4}" type="datetimeFigureOut">
               <a:rPr lang="en-US" smtClean="0"/>
-              <a:t>10/12/26</a:t>
+              <a:t>10/7/26</a:t>
             </a:fld>
             <a:endParaRPr lang="en-US"/>
           </a:p>
@@ -1714,7 +1714,7 @@
           <a:p>
             <a:fld id="{5BCAD085-E8A6-8845-BD4E-CB4CCA059FC4}" type="datetimeFigureOut">
               <a:rPr lang="en-US" smtClean="0"/>
-              <a:t>10/12/26</a:t>
+              <a:t>10/7/26</a:t>
             </a:fld>
             <a:endParaRPr lang="en-US"/>
           </a:p>
@@ -2133,7 +2133,7 @@
           <a:p>
             <a:fld id="{5BCAD085-E8A6-8845-BD4E-CB4CCA059FC4}" type="datetimeFigureOut">
               <a:rPr lang="en-US" smtClean="0"/>
-              <a:t>10/12/26</a:t>
+              <a:t>10/7/26</a:t>
             </a:fld>
             <a:endParaRPr lang="en-US"/>
           </a:p>
@@ -2250,7 +2250,7 @@
           <a:p>
             <a:fld id="{5BCAD085-E8A6-8845-BD4E-CB4CCA059FC4}" type="datetimeFigureOut">
               <a:rPr lang="en-US" smtClean="0"/>
-              <a:t>10/12/26</a:t>
+              <a:t>10/7/26</a:t>
             </a:fld>
             <a:endParaRPr lang="en-US"/>
           </a:p>
@@ -2345,7 +2345,7 @@
           <a:p>
             <a:fld id="{5BCAD085-E8A6-8845-BD4E-CB4CCA059FC4}" type="datetimeFigureOut">
               <a:rPr lang="en-US" smtClean="0"/>
-              <a:t>10/12/26</a:t>
+              <a:t>10/7/26</a:t>
             </a:fld>
             <a:endParaRPr lang="en-US"/>
           </a:p>
@@ -2620,7 +2620,7 @@
           <a:p>
             <a:fld id="{5BCAD085-E8A6-8845-BD4E-CB4CCA059FC4}" type="datetimeFigureOut">
               <a:rPr lang="en-US" smtClean="0"/>
-              <a:t>10/12/26</a:t>
+              <a:t>10/7/26</a:t>
             </a:fld>
             <a:endParaRPr lang="en-US"/>
           </a:p>
@@ -2872,7 +2872,7 @@
           <a:p>
             <a:fld id="{5BCAD085-E8A6-8845-BD4E-CB4CCA059FC4}" type="datetimeFigureOut">
               <a:rPr lang="en-US" smtClean="0"/>
-              <a:t>10/12/26</a:t>
+              <a:t>10/7/26</a:t>
             </a:fld>
             <a:endParaRPr lang="en-US"/>
           </a:p>
@@ -3083,7 +3083,7 @@
           <a:p>
             <a:fld id="{5BCAD085-E8A6-8845-BD4E-CB4CCA059FC4}" type="datetimeFigureOut">
               <a:rPr lang="en-US" smtClean="0"/>
-              <a:t>10/12/26</a:t>
+              <a:t>10/7/26</a:t>
             </a:fld>
             <a:endParaRPr lang="en-US"/>
           </a:p>
@@ -3164,146 +3164,6 @@
               <a:t>‹#›</a:t>
             </a:fld>
             <a:endParaRPr lang="en-US"/>
-          </a:p>
-        </p:txBody>
-      </p:sp>
-      <p:pic>
-        <p:nvPicPr>
-          <p:cNvPr id="7" name="Logo" descr="University of Southampton logo">
-            <a:extLst>
-              <a:ext uri="{FF2B5EF4-FFF2-40B4-BE49-F238E27FC236}">
-                <a16:creationId xmlns:a16="http://schemas.microsoft.com/office/drawing/2014/main" id="{4CDAB602-A350-5F02-2542-EE1B5012B87E}"/>
-              </a:ext>
-            </a:extLst>
-          </p:cNvPr>
-          <p:cNvPicPr>
-            <a:picLocks noChangeAspect="1"/>
-          </p:cNvPicPr>
-          <p:nvPr userDrawn="1"/>
-        </p:nvPicPr>
-        <p:blipFill>
-          <a:blip r:embed="rId13"/>
-          <a:stretch>
-            <a:fillRect/>
-          </a:stretch>
-        </p:blipFill>
-        <p:spPr>
-          <a:xfrm>
-            <a:off x="7406640" y="6384033"/>
-            <a:ext cx="1371600" cy="291086"/>
-          </a:xfrm>
-          <a:prstGeom prst="rect">
-            <a:avLst/>
-          </a:prstGeom>
-        </p:spPr>
-      </p:pic>
-      <p:sp>
-        <p:nvSpPr>
-          <p:cNvPr id="8" name="Footer slide number">
-            <a:extLst>
-              <a:ext uri="{FF2B5EF4-FFF2-40B4-BE49-F238E27FC236}">
-                <a16:creationId xmlns:a16="http://schemas.microsoft.com/office/drawing/2014/main" id="{7C4F2338-8643-7AC2-221A-66670A2D95C8}"/>
-              </a:ext>
-            </a:extLst>
-          </p:cNvPr>
-          <p:cNvSpPr txBox="1"/>
-          <p:nvPr userDrawn="1"/>
-        </p:nvSpPr>
-        <p:spPr>
-          <a:xfrm>
-            <a:off x="365760" y="6384033"/>
-            <a:ext cx="457200" cy="291086"/>
-          </a:xfrm>
-          <a:prstGeom prst="rect">
-            <a:avLst/>
-          </a:prstGeom>
-          <a:noFill/>
-        </p:spPr>
-        <p:txBody>
-          <a:bodyPr wrap="square" lIns="0" tIns="0" rIns="0" bIns="0" anchor="ctr">
-            <a:noAutofit/>
-          </a:bodyPr>
-          <a:lstStyle/>
-          <a:p>
-            <a:fld id="{B6F15528-21DE-4FAA-801E-634DDDAF4B2B}" type="slidenum">
-              <a:rPr lang="en-GB" sz="1400" dirty="0">
-                <a:solidFill>
-                  <a:srgbClr val="1F497D"/>
-                </a:solidFill>
-              </a:rPr>
-              <a:t>‹#›</a:t>
-            </a:fld>
-            <a:endParaRPr lang="en-GB" sz="1400" dirty="0">
-              <a:solidFill>
-                <a:srgbClr val="1F497D"/>
-              </a:solidFill>
-            </a:endParaRPr>
-          </a:p>
-        </p:txBody>
-      </p:sp>
-      <p:sp>
-        <p:nvSpPr>
-          <p:cNvPr id="9" name="Footer SEAtS">
-            <a:extLst>
-              <a:ext uri="{FF2B5EF4-FFF2-40B4-BE49-F238E27FC236}">
-                <a16:creationId xmlns:a16="http://schemas.microsoft.com/office/drawing/2014/main" id="{6CC30E9B-3348-9C5B-131A-DB8D58B63FA3}"/>
-              </a:ext>
-            </a:extLst>
-          </p:cNvPr>
-          <p:cNvSpPr txBox="1"/>
-          <p:nvPr userDrawn="1"/>
-        </p:nvSpPr>
-        <p:spPr>
-          <a:xfrm>
-            <a:off x="742950" y="6430390"/>
-            <a:ext cx="3200400" cy="291086"/>
-          </a:xfrm>
-          <a:prstGeom prst="rect">
-            <a:avLst/>
-          </a:prstGeom>
-          <a:noFill/>
-        </p:spPr>
-        <p:txBody>
-          <a:bodyPr wrap="square" lIns="0" tIns="0" rIns="0" bIns="0" anchor="ctr">
-            <a:noAutofit/>
-          </a:bodyPr>
-          <a:lstStyle/>
-          <a:p>
-            <a:pPr marL="0" marR="0" indent="0" algn="l" defTabSz="457200" rtl="0" eaLnBrk="1" fontAlgn="auto" latinLnBrk="0" hangingPunct="1">
-              <a:lnSpc>
-                <a:spcPct val="100000"/>
-              </a:lnSpc>
-              <a:spcBef>
-                <a:spcPts val="0"/>
-              </a:spcBef>
-              <a:spcAft>
-                <a:spcPts val="0"/>
-              </a:spcAft>
-              <a:buClrTx/>
-              <a:buSzTx/>
-              <a:buFontTx/>
-              <a:buNone/>
-              <a:tabLst/>
-              <a:defRPr/>
-            </a:pPr>
-            <a:r>
-              <a:rPr lang="en-GB" sz="1000" b="1" dirty="0">
-                <a:solidFill>
-                  <a:srgbClr val="1F497D"/>
-                </a:solidFill>
-              </a:rPr>
-              <a:t>SEAtS | 467636</a:t>
-            </a:r>
-          </a:p>
-          <a:p>
-            <a:r>
-              <a:rPr lang="en-GB" sz="800" b="1" dirty="0">
-                <a:solidFill>
-                  <a:srgbClr val="8C8C8C"/>
-                </a:solidFill>
-              </a:rPr>
-              <a:t>© University of Southampton</a:t>
-            </a:r>
           </a:p>
         </p:txBody>
       </p:sp>
@@ -7456,71 +7316,6 @@
                 <a:schemeClr val="tx2"/>
               </a:solidFill>
             </a:endParaRPr>
-          </a:p>
-        </p:txBody>
-      </p:sp>
-      <p:pic>
-        <p:nvPicPr>
-          <p:cNvPr id="3" name="Picture 2" descr="A qr code with a few squares&#10;&#10;AI-generated content may be incorrect.">
-            <a:extLst>
-              <a:ext uri="{FF2B5EF4-FFF2-40B4-BE49-F238E27FC236}">
-                <a16:creationId xmlns:a16="http://schemas.microsoft.com/office/drawing/2014/main" id="{D46EB5BB-E394-6C6B-9689-8549239F82A3}"/>
-              </a:ext>
-            </a:extLst>
-          </p:cNvPr>
-          <p:cNvPicPr>
-            <a:picLocks noChangeAspect="1"/>
-          </p:cNvPicPr>
-          <p:nvPr/>
-        </p:nvPicPr>
-        <p:blipFill>
-          <a:blip r:embed="rId2"/>
-          <a:stretch>
-            <a:fillRect/>
-          </a:stretch>
-        </p:blipFill>
-        <p:spPr>
-          <a:xfrm>
-            <a:off x="3414580" y="3338689"/>
-            <a:ext cx="2314840" cy="2311400"/>
-          </a:xfrm>
-          <a:prstGeom prst="rect">
-            <a:avLst/>
-          </a:prstGeom>
-        </p:spPr>
-      </p:pic>
-      <p:sp>
-        <p:nvSpPr>
-          <p:cNvPr id="6" name="TextBox 5">
-            <a:extLst>
-              <a:ext uri="{FF2B5EF4-FFF2-40B4-BE49-F238E27FC236}">
-                <a16:creationId xmlns:a16="http://schemas.microsoft.com/office/drawing/2014/main" id="{84A5754B-7265-89F4-32C6-5C95B1841DE6}"/>
-              </a:ext>
-            </a:extLst>
-          </p:cNvPr>
-          <p:cNvSpPr txBox="1"/>
-          <p:nvPr/>
-        </p:nvSpPr>
-        <p:spPr>
-          <a:xfrm>
-            <a:off x="3965222" y="5742001"/>
-            <a:ext cx="1213556" cy="461665"/>
-          </a:xfrm>
-          <a:prstGeom prst="rect">
-            <a:avLst/>
-          </a:prstGeom>
-          <a:noFill/>
-        </p:spPr>
-        <p:txBody>
-          <a:bodyPr wrap="square">
-            <a:spAutoFit/>
-          </a:bodyPr>
-          <a:lstStyle/>
-          <a:p>
-            <a:r>
-              <a:rPr lang="en-001" sz="2400" dirty="0"/>
-              <a:t>467636</a:t>
-            </a:r>
           </a:p>
         </p:txBody>
       </p:sp>

</xml_diff>